<commit_message>
Add demo video and final presentation
</commit_message>
<xml_diff>
--- a/presentation/HW3_Third-Party-Data-Dashboard.pptx
+++ b/presentation/HW3_Third-Party-Data-Dashboard.pptx
@@ -5624,7 +5624,7 @@
                   <a:schemeClr val="tx2"/>
                 </a:solidFill>
               </a:rPr>
-              <a:t>Token and app password are environment variables; .mcp.json only has ${...} placeholders</a:t>
+              <a:t>GitHub token is an environment variable; .mcp.json only has a ${...} placeholder. Gmail needs no secret at all: it's an OAuth connector tied to the account</a:t>
             </a:r>
             <a:endParaRPr lang="en-US" sz="1400" dirty="0"/>
           </a:p>
@@ -6231,12 +6231,12 @@
               <a:buNone/>
             </a:pPr>
             <a:r>
-              <a:rPr lang="en-US" sz="1150" dirty="0">
+              <a:rPr lang="en-US" sz="1000" dirty="0">
                 <a:solidFill>
                   <a:schemeClr val="tx1"/>
                 </a:solidFill>
               </a:rPr>
-              <a:t>Gmail's official MCP server needs a Google Cloud project and OAuth client, so I used an IMAP community server with an app password</a:t>
+              <a:t>Google's own Gmail MCP server needs a Google Cloud project enrolled in Google's Developer Preview Program, so I used Anthropic's own official Gmail connector instead (OAuth, no Google Cloud setup needed)</a:t>
             </a:r>
             <a:endParaRPr lang="en-US" sz="1150" dirty="0"/>
           </a:p>
@@ -6362,7 +6362,7 @@
                   <a:schemeClr val="tx1"/>
                 </a:solidFill>
               </a:rPr>
-              <a:t>Each service logs in a different way: OAuth, a token or an app password</a:t>
+              <a:t>Each service logs in a different way: OAuth or a personal access token</a:t>
             </a:r>
             <a:endParaRPr lang="en-US" sz="1150" dirty="0"/>
           </a:p>
@@ -11111,7 +11111,7 @@
                 <a:ea typeface="Courier New" pitchFamily="34" charset="-122"/>
                 <a:cs typeface="Courier New" pitchFamily="34" charset="-120"/>
               </a:rPr>
-              <a:t>"gmail": npx gmail-mcp-imap@1.0.3</a:t>
+              <a:t>"gmail": claude.ai Gmail connector</a:t>
             </a:r>
             <a:endParaRPr lang="en-US" sz="850" dirty="0"/>
           </a:p>
@@ -11128,7 +11128,7 @@
                 <a:ea typeface="Courier New" pitchFamily="34" charset="-122"/>
                 <a:cs typeface="Courier New" pitchFamily="34" charset="-120"/>
               </a:rPr>
-              <a:t>  GMAIL_APP_PASSWORD=${GMAIL_APP_PASSWORD}</a:t>
+              <a:t>  (account-level, not in .mcp.json)</a:t>
             </a:r>
             <a:endParaRPr lang="en-US" sz="850" dirty="0"/>
           </a:p>
@@ -11756,7 +11756,7 @@
                   <a:schemeClr val="tx1"/>
                 </a:solidFill>
               </a:rPr>
-              <a:t>gmail-mcp-imap</a:t>
+              <a:t>Anthropic's official Gmail connector</a:t>
             </a:r>
             <a:endParaRPr lang="en-US" sz="1200" dirty="0"/>
           </a:p>
@@ -11770,7 +11770,7 @@
                   <a:schemeClr val="tx2"/>
                 </a:solidFill>
               </a:rPr>
-              <a:t>App password over IMAP (env variable)</a:t>
+              <a:t>OAuth (claude.ai Settings → Connectors)</a:t>
             </a:r>
             <a:endParaRPr lang="en-US" sz="1200" dirty="0"/>
           </a:p>
@@ -11793,11 +11793,11 @@
             </a:avLst>
           </a:prstGeom>
           <a:solidFill>
-            <a:srgbClr val="F26B3A"/>
+            <a:srgbClr val="2E9E6B"/>
           </a:solidFill>
           <a:ln w="12700">
             <a:solidFill>
-              <a:srgbClr val="F26B3A"/>
+              <a:srgbClr val="2E9E6B"/>
             </a:solidFill>
             <a:prstDash val="solid"/>
           </a:ln>
@@ -11840,7 +11840,7 @@
                   <a:srgbClr val="FFFFFF"/>
                 </a:solidFill>
               </a:rPr>
-              <a:t>Community</a:t>
+              <a:t>Official</a:t>
             </a:r>
             <a:endParaRPr lang="en-US" sz="900" dirty="0"/>
           </a:p>
@@ -12375,7 +12375,7 @@
                   <a:schemeClr val="tx1"/>
                 </a:solidFill>
               </a:rPr>
-              <a:t>Connected with the gmail-mcp-imap server using a Gmail app password</a:t>
+              <a:t>Connected with Anthropic's official claude.ai Gmail connector, signing in with OAuth</a:t>
             </a:r>
             <a:endParaRPr lang="en-US" sz="1100" dirty="0"/>
           </a:p>

</xml_diff>